<commit_message>
last updates before URCA submission
</commit_message>
<xml_diff>
--- a/publications/urca-2026/Poster.pptx
+++ b/publications/urca-2026/Poster.pptx
@@ -14,30 +14,25 @@
   <p:notesSz cx="6950075" cy="9236075"/>
   <p:embeddedFontLst>
     <p:embeddedFont>
-      <p:font typeface="Adelle Sans Devanagari" panose="02000503000000020004" pitchFamily="2" charset="-78"/>
+      <p:font typeface="Corbel" panose="020B0503020204020204" pitchFamily="34" charset="0"/>
       <p:regular r:id="rId4"/>
       <p:bold r:id="rId5"/>
-    </p:embeddedFont>
-    <p:embeddedFont>
-      <p:font typeface="Corbel" panose="020B0503020204020204" pitchFamily="34" charset="0"/>
-      <p:regular r:id="rId6"/>
-      <p:bold r:id="rId7"/>
-      <p:italic r:id="rId8"/>
-      <p:boldItalic r:id="rId9"/>
+      <p:italic r:id="rId6"/>
+      <p:boldItalic r:id="rId7"/>
     </p:embeddedFont>
     <p:embeddedFont>
       <p:font typeface="EB Garamond" pitchFamily="2" charset="0"/>
-      <p:regular r:id="rId10"/>
-      <p:bold r:id="rId11"/>
-      <p:italic r:id="rId12"/>
-      <p:boldItalic r:id="rId13"/>
+      <p:regular r:id="rId8"/>
+      <p:bold r:id="rId9"/>
+      <p:italic r:id="rId10"/>
+      <p:boldItalic r:id="rId11"/>
     </p:embeddedFont>
     <p:embeddedFont>
       <p:font typeface="Verdana" panose="020B0604030504040204" pitchFamily="34" charset="0"/>
-      <p:regular r:id="rId14"/>
-      <p:bold r:id="rId15"/>
-      <p:italic r:id="rId16"/>
-      <p:boldItalic r:id="rId17"/>
+      <p:regular r:id="rId12"/>
+      <p:bold r:id="rId13"/>
+      <p:italic r:id="rId14"/>
+      <p:boldItalic r:id="rId15"/>
     </p:embeddedFont>
   </p:embeddedFontLst>
   <p:defaultTextStyle>
@@ -11507,7 +11502,7 @@
         </p:nvSpPr>
         <p:spPr>
           <a:xfrm>
-            <a:off x="150992" y="1208897"/>
+            <a:off x="-327981" y="686381"/>
             <a:ext cx="44450577" cy="6225840"/>
           </a:xfrm>
           <a:prstGeom prst="rect">
@@ -11563,7 +11558,7 @@
         <p:spPr>
           <a:xfrm>
             <a:off x="33184530" y="8746424"/>
-            <a:ext cx="10018879" cy="8863925"/>
+            <a:ext cx="10018879" cy="7940595"/>
           </a:xfrm>
           <a:prstGeom prst="rect">
             <a:avLst/>
@@ -11584,7 +11579,7 @@
                 <a:latin typeface="EB Garamond" pitchFamily="2" charset="0"/>
                 <a:ea typeface="EB Garamond" pitchFamily="2" charset="0"/>
               </a:rPr>
-              <a:t>GDPR research has largely focused on legal compliance obligations and enforcement (Baldwin et al., 2011). Economic studies document reduced venture investment post-GDPR (Jia et al., 2021) and declines in web traffic and e-commerce revenue (Goldberg et al., 2022), while others find GDPR increased data input costs by 22% on average, with larger firms less affected (Demirer et al., 2024). Regulatory uncertainty — distinct from compliance cost — is theorized to produce overcompliance or avoidance behaviors as firms adopt precautionary interpretations under ambiguous rules (Bardach &amp; Kagan, 2002; Baldwin et al., 2011). </a:t>
+              <a:t>GDPR research largely focuses on legal compliance obligations and enforcement (Baldwin et al., 2011). Economic studies document reduced venture investment post-GDPR (Jia et al., 2021) and declines in web traffic and e-commerce revenue (Goldberg et al., 2022), while others find GDPR increased data input costs by 22% on average, with larger firms less affected (Demirer et al., 2024). Regulatory uncertainty is theorized to produce overcompliance or avoidance behaviors as firms adopt precautionary interpretations under ambiguous rules (Baldwin et al., 2011). </a:t>
             </a:r>
           </a:p>
           <a:p>
@@ -11628,7 +11623,7 @@
                 <a:latin typeface="EB Garamond" pitchFamily="2" charset="0"/>
                 <a:ea typeface="EB Garamond" pitchFamily="2" charset="0"/>
               </a:rPr>
-              <a:t>This study fills that gap using a 2024 cross-sectional survey of 637 German firms (ZEW), isolating the independent effects of uncertainty, burden, and opportunity orientation across eight behavioral outcomes.</a:t>
+              <a:t>This study fills that gap using a cross-sectional survey of 637 German firms (ZEW), isolating independent effects of uncertainty, burden, and opportunity orientation across behavioral outcomes.</a:t>
             </a:r>
           </a:p>
         </p:txBody>
@@ -11687,7 +11682,7 @@
         </p:nvSpPr>
         <p:spPr>
           <a:xfrm>
-            <a:off x="1131985" y="19156913"/>
+            <a:off x="957999" y="19158975"/>
             <a:ext cx="9885343" cy="13480573"/>
           </a:xfrm>
           <a:prstGeom prst="rect">
@@ -11907,8 +11902,8 @@
                 <a:solidFill>
                   <a:schemeClr val="lt1"/>
                 </a:solidFill>
-                <a:latin typeface="Adelle Sans Devanagari" panose="02000503000000020004" pitchFamily="2" charset="-78"/>
-                <a:ea typeface="Helvetica Neue"/>
+                <a:latin typeface="EB Garamond" pitchFamily="2" charset="0"/>
+                <a:ea typeface="EB Garamond" pitchFamily="2" charset="0"/>
                 <a:cs typeface="Adelle Sans Devanagari" panose="02000503000000020004" pitchFamily="2" charset="-78"/>
                 <a:sym typeface="Helvetica Neue"/>
               </a:rPr>
@@ -11930,8 +11925,8 @@
                 <a:solidFill>
                   <a:schemeClr val="lt1"/>
                 </a:solidFill>
-                <a:latin typeface="Adelle Sans Devanagari" panose="02000503000000020004" pitchFamily="2" charset="-78"/>
-                <a:ea typeface="Helvetica Neue"/>
+                <a:latin typeface="EB Garamond" pitchFamily="2" charset="0"/>
+                <a:ea typeface="EB Garamond" pitchFamily="2" charset="0"/>
                 <a:cs typeface="Adelle Sans Devanagari" panose="02000503000000020004" pitchFamily="2" charset="-78"/>
                 <a:sym typeface="Helvetica Neue"/>
               </a:rPr>
@@ -11942,8 +11937,8 @@
                 <a:solidFill>
                   <a:schemeClr val="lt1"/>
                 </a:solidFill>
-                <a:latin typeface="Adelle Sans Devanagari" panose="02000503000000020004" pitchFamily="2" charset="-78"/>
-                <a:ea typeface="Helvetica Neue"/>
+                <a:latin typeface="EB Garamond" pitchFamily="2" charset="0"/>
+                <a:ea typeface="EB Garamond" pitchFamily="2" charset="0"/>
                 <a:cs typeface="Adelle Sans Devanagari" panose="02000503000000020004" pitchFamily="2" charset="-78"/>
                 <a:sym typeface="Helvetica Neue"/>
               </a:rPr>
@@ -11954,15 +11949,16 @@
                 <a:solidFill>
                   <a:schemeClr val="lt1"/>
                 </a:solidFill>
-                <a:latin typeface="Adelle Sans Devanagari" panose="02000503000000020004" pitchFamily="2" charset="-78"/>
-                <a:ea typeface="Helvetica Neue"/>
+                <a:latin typeface="EB Garamond" pitchFamily="2" charset="0"/>
+                <a:ea typeface="EB Garamond" pitchFamily="2" charset="0"/>
                 <a:cs typeface="Adelle Sans Devanagari" panose="02000503000000020004" pitchFamily="2" charset="-78"/>
                 <a:sym typeface="Helvetica Neue"/>
               </a:rPr>
               <a:t>, Dr. Michael Price</a:t>
             </a:r>
             <a:endParaRPr lang="en-US" sz="6000" dirty="0">
-              <a:latin typeface="Adelle Sans Devanagari" panose="02000503000000020004" pitchFamily="2" charset="-78"/>
+              <a:latin typeface="EB Garamond" pitchFamily="2" charset="0"/>
+              <a:ea typeface="EB Garamond" pitchFamily="2" charset="0"/>
               <a:cs typeface="Adelle Sans Devanagari" panose="02000503000000020004" pitchFamily="2" charset="-78"/>
             </a:endParaRPr>
           </a:p>
@@ -11981,8 +11977,8 @@
                 <a:solidFill>
                   <a:schemeClr val="lt1"/>
                 </a:solidFill>
-                <a:latin typeface="Adelle Sans Devanagari" panose="02000503000000020004" pitchFamily="2" charset="-78"/>
-                <a:ea typeface="Helvetica Neue"/>
+                <a:latin typeface="EB Garamond" pitchFamily="2" charset="0"/>
+                <a:ea typeface="EB Garamond" pitchFamily="2" charset="0"/>
                 <a:cs typeface="Adelle Sans Devanagari" panose="02000503000000020004" pitchFamily="2" charset="-78"/>
                 <a:sym typeface="Helvetica Neue"/>
               </a:rPr>
@@ -11992,8 +11988,8 @@
               <a:solidFill>
                 <a:schemeClr val="lt1"/>
               </a:solidFill>
-              <a:latin typeface="Adelle Sans Devanagari" panose="02000503000000020004" pitchFamily="2" charset="-78"/>
-              <a:ea typeface="Helvetica Neue"/>
+              <a:latin typeface="EB Garamond" pitchFamily="2" charset="0"/>
+              <a:ea typeface="EB Garamond" pitchFamily="2" charset="0"/>
               <a:cs typeface="Adelle Sans Devanagari" panose="02000503000000020004" pitchFamily="2" charset="-78"/>
               <a:sym typeface="Helvetica Neue"/>
             </a:endParaRPr>
@@ -12120,7 +12116,7 @@
         </p:nvSpPr>
         <p:spPr>
           <a:xfrm>
-            <a:off x="12037121" y="7607074"/>
+            <a:off x="12380084" y="7606393"/>
             <a:ext cx="19522440" cy="914400"/>
           </a:xfrm>
           <a:prstGeom prst="rect">
@@ -12175,7 +12171,7 @@
         </p:nvSpPr>
         <p:spPr>
           <a:xfrm>
-            <a:off x="12554901" y="7663904"/>
+            <a:off x="12897864" y="7663223"/>
             <a:ext cx="18355683" cy="769442"/>
           </a:xfrm>
           <a:prstGeom prst="rect">
@@ -12232,7 +12228,7 @@
         </p:nvSpPr>
         <p:spPr>
           <a:xfrm>
-            <a:off x="924516" y="17900545"/>
+            <a:off x="750530" y="17902607"/>
             <a:ext cx="10241280" cy="914400"/>
           </a:xfrm>
           <a:prstGeom prst="rect">
@@ -12287,7 +12283,7 @@
         </p:nvSpPr>
         <p:spPr>
           <a:xfrm>
-            <a:off x="1271073" y="17964474"/>
+            <a:off x="1097087" y="17966536"/>
             <a:ext cx="9607873" cy="769441"/>
           </a:xfrm>
           <a:prstGeom prst="rect">
@@ -12371,7 +12367,7 @@
         </p:nvSpPr>
         <p:spPr>
           <a:xfrm>
-            <a:off x="32612708" y="23952021"/>
+            <a:off x="32999548" y="24278792"/>
             <a:ext cx="10241280" cy="914400"/>
           </a:xfrm>
           <a:prstGeom prst="rect">
@@ -12426,7 +12422,7 @@
         </p:nvSpPr>
         <p:spPr>
           <a:xfrm>
-            <a:off x="32613172" y="23855183"/>
+            <a:off x="33000012" y="24181954"/>
             <a:ext cx="10236053" cy="914400"/>
           </a:xfrm>
           <a:prstGeom prst="rect">
@@ -12478,7 +12474,7 @@
         </p:nvSpPr>
         <p:spPr>
           <a:xfrm>
-            <a:off x="32796052" y="25200805"/>
+            <a:off x="33182892" y="25359132"/>
             <a:ext cx="9583737" cy="7017265"/>
           </a:xfrm>
           <a:prstGeom prst="rect">
@@ -12612,7 +12608,7 @@
         </p:nvSpPr>
         <p:spPr>
           <a:xfrm>
-            <a:off x="861777" y="7591425"/>
+            <a:off x="687791" y="7593487"/>
             <a:ext cx="10241280" cy="914400"/>
           </a:xfrm>
           <a:prstGeom prst="rect">
@@ -12667,7 +12663,7 @@
         </p:nvSpPr>
         <p:spPr>
           <a:xfrm>
-            <a:off x="1372767" y="7674887"/>
+            <a:off x="1198781" y="7676949"/>
             <a:ext cx="9083675" cy="769938"/>
           </a:xfrm>
           <a:prstGeom prst="rect">
@@ -12724,7 +12720,7 @@
         </p:nvSpPr>
         <p:spPr>
           <a:xfrm>
-            <a:off x="12037121" y="18286243"/>
+            <a:off x="12380084" y="16685362"/>
             <a:ext cx="19522440" cy="914400"/>
           </a:xfrm>
           <a:prstGeom prst="rect">
@@ -12779,7 +12775,7 @@
         </p:nvSpPr>
         <p:spPr>
           <a:xfrm>
-            <a:off x="12554901" y="18343073"/>
+            <a:off x="12897864" y="16742192"/>
             <a:ext cx="18355683" cy="769442"/>
           </a:xfrm>
           <a:prstGeom prst="rect">
@@ -12836,7 +12832,7 @@
         </p:nvSpPr>
         <p:spPr>
           <a:xfrm>
-            <a:off x="1080319" y="8680605"/>
+            <a:off x="906333" y="8682667"/>
             <a:ext cx="9809347" cy="8863925"/>
           </a:xfrm>
           <a:prstGeom prst="rect">
@@ -13000,14 +12996,14 @@
           <p:nvPr>
             <p:extLst>
               <p:ext uri="{D42A27DB-BD31-4B8C-83A1-F6EECF244321}">
-                <p14:modId xmlns:p14="http://schemas.microsoft.com/office/powerpoint/2010/main" val="2979557986"/>
+                <p14:modId xmlns:p14="http://schemas.microsoft.com/office/powerpoint/2010/main" val="1266443454"/>
               </p:ext>
             </p:extLst>
           </p:nvPr>
         </p:nvGraphicFramePr>
         <p:xfrm>
-          <a:off x="12823848" y="9352762"/>
-          <a:ext cx="5232964" cy="8122791"/>
+          <a:off x="13166810" y="9352081"/>
+          <a:ext cx="5869600" cy="6877815"/>
         </p:xfrm>
         <a:graphic>
           <a:graphicData uri="http://schemas.openxmlformats.org/drawingml/2006/table">
@@ -13016,14 +13012,14 @@
                 <a:tableStyleId>{073A0DAA-6AF3-43AB-8588-CEC1D06C72B9}</a:tableStyleId>
               </a:tblPr>
               <a:tblGrid>
-                <a:gridCol w="2616482">
+                <a:gridCol w="2934800">
                   <a:extLst>
                     <a:ext uri="{9D8B030D-6E8A-4147-A177-3AD203B41FA5}">
                       <a16:colId xmlns:a16="http://schemas.microsoft.com/office/drawing/2014/main" val="1376709011"/>
                     </a:ext>
                   </a:extLst>
                 </a:gridCol>
-                <a:gridCol w="2616482">
+                <a:gridCol w="2934800">
                   <a:extLst>
                     <a:ext uri="{9D8B030D-6E8A-4147-A177-3AD203B41FA5}">
                       <a16:colId xmlns:a16="http://schemas.microsoft.com/office/drawing/2014/main" val="2908749893"/>
@@ -13031,7 +13027,7 @@
                   </a:extLst>
                 </a:gridCol>
               </a:tblGrid>
-              <a:tr h="641273">
+              <a:tr h="537025">
                 <a:tc gridSpan="2">
                   <a:txBody>
                     <a:bodyPr/>
@@ -13065,12 +13061,13 @@
                   </a:ext>
                 </a:extLst>
               </a:tr>
-              <a:tr h="1175667">
+              <a:tr h="984546">
                 <a:tc>
                   <a:txBody>
                     <a:bodyPr/>
                     <a:lstStyle/>
                     <a:p>
+                      <a:pPr algn="ctr"/>
                       <a:r>
                         <a:rPr lang="en-US" sz="3000" dirty="0">
                           <a:solidFill>
@@ -13090,6 +13087,7 @@
                     <a:bodyPr/>
                     <a:lstStyle/>
                     <a:p>
+                      <a:pPr algn="ctr"/>
                       <a:r>
                         <a:rPr lang="en-US" sz="3000" dirty="0">
                           <a:solidFill>
@@ -13110,12 +13108,13 @@
                   </a:ext>
                 </a:extLst>
               </a:tr>
-              <a:tr h="1175667">
+              <a:tr h="984546">
                 <a:tc>
                   <a:txBody>
                     <a:bodyPr/>
                     <a:lstStyle/>
                     <a:p>
+                      <a:pPr algn="ctr"/>
                       <a:r>
                         <a:rPr lang="en-US" sz="3000" dirty="0">
                           <a:solidFill>
@@ -13135,6 +13134,7 @@
                     <a:bodyPr/>
                     <a:lstStyle/>
                     <a:p>
+                      <a:pPr algn="ctr"/>
                       <a:r>
                         <a:rPr lang="en-US" sz="3000" dirty="0">
                           <a:solidFill>
@@ -13155,12 +13155,13 @@
                   </a:ext>
                 </a:extLst>
               </a:tr>
-              <a:tr h="2778850">
+              <a:tr h="2327109">
                 <a:tc>
                   <a:txBody>
                     <a:bodyPr/>
                     <a:lstStyle/>
                     <a:p>
+                      <a:pPr algn="ctr"/>
                       <a:r>
                         <a:rPr lang="en-US" sz="3000" dirty="0">
                           <a:solidFill>
@@ -13180,6 +13181,7 @@
                     <a:bodyPr/>
                     <a:lstStyle/>
                     <a:p>
+                      <a:pPr algn="ctr"/>
                       <a:r>
                         <a:rPr lang="en-US" sz="3000" dirty="0">
                           <a:solidFill>
@@ -13200,12 +13202,13 @@
                   </a:ext>
                 </a:extLst>
               </a:tr>
-              <a:tr h="1175667">
+              <a:tr h="984546">
                 <a:tc>
                   <a:txBody>
                     <a:bodyPr/>
                     <a:lstStyle/>
                     <a:p>
+                      <a:pPr algn="ctr"/>
                       <a:r>
                         <a:rPr lang="en-US" sz="3000" dirty="0">
                           <a:solidFill>
@@ -13225,6 +13228,7 @@
                     <a:bodyPr/>
                     <a:lstStyle/>
                     <a:p>
+                      <a:pPr algn="ctr"/>
                       <a:r>
                         <a:rPr lang="en-US" sz="3000" dirty="0">
                           <a:solidFill>
@@ -13245,12 +13249,13 @@
                   </a:ext>
                 </a:extLst>
               </a:tr>
-              <a:tr h="1175667">
+              <a:tr h="984546">
                 <a:tc>
                   <a:txBody>
                     <a:bodyPr/>
                     <a:lstStyle/>
                     <a:p>
+                      <a:pPr algn="ctr"/>
                       <a:r>
                         <a:rPr lang="en-US" sz="3000" dirty="0">
                           <a:solidFill>
@@ -13270,6 +13275,7 @@
                     <a:bodyPr/>
                     <a:lstStyle/>
                     <a:p>
+                      <a:pPr algn="ctr"/>
                       <a:r>
                         <a:rPr lang="en-US" sz="3000" dirty="0">
                           <a:solidFill>
@@ -13308,8 +13314,8 @@
         </p:nvSpPr>
         <p:spPr>
           <a:xfrm>
-            <a:off x="19808114" y="8971896"/>
-            <a:ext cx="10666698" cy="8863925"/>
+            <a:off x="19745325" y="8971215"/>
+            <a:ext cx="11715750" cy="7478930"/>
           </a:xfrm>
           <a:prstGeom prst="rect">
             <a:avLst/>
@@ -13572,46 +13578,7 @@
                 <a:latin typeface="EB Garamond" pitchFamily="2" charset="0"/>
                 <a:ea typeface="EB Garamond" pitchFamily="2" charset="0"/>
               </a:rPr>
-              <a:t>: </a:t>
-            </a:r>
-          </a:p>
-          <a:p>
-            <a:pPr marL="457200" indent="-457200">
-              <a:buFont typeface="Arial" panose="020B0604020202020204" pitchFamily="34" charset="0"/>
-              <a:buChar char="•"/>
-            </a:pPr>
-            <a:r>
-              <a:rPr lang="en-US" sz="3000" dirty="0">
-                <a:latin typeface="EB Garamond" pitchFamily="2" charset="0"/>
-                <a:ea typeface="EB Garamond" pitchFamily="2" charset="0"/>
-              </a:rPr>
-              <a:t>Uncertainty (high vs. low)</a:t>
-            </a:r>
-          </a:p>
-          <a:p>
-            <a:pPr marL="457200" indent="-457200">
-              <a:buFont typeface="Arial" panose="020B0604020202020204" pitchFamily="34" charset="0"/>
-              <a:buChar char="•"/>
-            </a:pPr>
-            <a:r>
-              <a:rPr lang="en-US" sz="3000" dirty="0">
-                <a:latin typeface="EB Garamond" pitchFamily="2" charset="0"/>
-                <a:ea typeface="EB Garamond" pitchFamily="2" charset="0"/>
-              </a:rPr>
-              <a:t>Compliance burden (high vs. low)</a:t>
-            </a:r>
-          </a:p>
-          <a:p>
-            <a:pPr marL="457200" indent="-457200">
-              <a:buFont typeface="Arial" panose="020B0604020202020204" pitchFamily="34" charset="0"/>
-              <a:buChar char="•"/>
-            </a:pPr>
-            <a:r>
-              <a:rPr lang="en-US" sz="3000" dirty="0">
-                <a:latin typeface="EB Garamond" pitchFamily="2" charset="0"/>
-                <a:ea typeface="EB Garamond" pitchFamily="2" charset="0"/>
-              </a:rPr>
-              <a:t>Opportunity orientation (high vs. low)</a:t>
+              <a:t>: Uncertainty, Compliance burden, Opportunity orientation</a:t>
             </a:r>
           </a:p>
           <a:p>
@@ -13678,7 +13645,7 @@
         </p:nvSpPr>
         <p:spPr>
           <a:xfrm>
-            <a:off x="12725653" y="28505516"/>
+            <a:off x="12725653" y="28307804"/>
             <a:ext cx="5598923" cy="3323987"/>
           </a:xfrm>
           <a:prstGeom prst="rect">
@@ -13803,7 +13770,7 @@
         </p:nvSpPr>
         <p:spPr>
           <a:xfrm>
-            <a:off x="19036410" y="28505516"/>
+            <a:off x="19036410" y="28307804"/>
             <a:ext cx="5598923" cy="3323987"/>
           </a:xfrm>
           <a:prstGeom prst="rect">
@@ -13915,8 +13882,8 @@
         </p:nvSpPr>
         <p:spPr>
           <a:xfrm>
-            <a:off x="25435337" y="28505516"/>
-            <a:ext cx="5598923" cy="3323987"/>
+            <a:off x="25435337" y="28307804"/>
+            <a:ext cx="6025738" cy="3323987"/>
           </a:xfrm>
           <a:prstGeom prst="rect">
             <a:avLst/>
@@ -13997,777 +13964,401 @@
           </a:p>
         </p:txBody>
       </p:sp>
-      <p:graphicFrame>
-        <p:nvGraphicFramePr>
-          <p:cNvPr id="12" name="Table 11">
+      <p:pic>
+        <p:nvPicPr>
+          <p:cNvPr id="14" name="Picture 13" descr="A graph with colorful lines&#10;&#10;AI-generated content may be incorrect.">
             <a:extLst>
               <a:ext uri="{FF2B5EF4-FFF2-40B4-BE49-F238E27FC236}">
-                <a16:creationId xmlns:a16="http://schemas.microsoft.com/office/drawing/2014/main" id="{DA497FD5-5265-7418-056A-DA3CFE99383C}"/>
+                <a16:creationId xmlns:a16="http://schemas.microsoft.com/office/drawing/2014/main" id="{E46E74DE-B421-B1DB-196D-1CAB2282C3DA}"/>
               </a:ext>
             </a:extLst>
           </p:cNvPr>
-          <p:cNvGraphicFramePr>
-            <a:graphicFrameLocks noGrp="1"/>
-          </p:cNvGraphicFramePr>
-          <p:nvPr>
-            <p:extLst>
-              <p:ext uri="{D42A27DB-BD31-4B8C-83A1-F6EECF244321}">
-                <p14:modId xmlns:p14="http://schemas.microsoft.com/office/powerpoint/2010/main" val="2360239402"/>
-              </p:ext>
-            </p:extLst>
-          </p:nvPr>
-        </p:nvGraphicFramePr>
-        <p:xfrm>
-          <a:off x="12554900" y="22693376"/>
-          <a:ext cx="17919912" cy="4937760"/>
-        </p:xfrm>
-        <a:graphic>
-          <a:graphicData uri="http://schemas.openxmlformats.org/drawingml/2006/table">
-            <a:tbl>
-              <a:tblPr firstRow="1" bandRow="1">
-                <a:tableStyleId>{073A0DAA-6AF3-43AB-8588-CEC1D06C72B9}</a:tableStyleId>
-              </a:tblPr>
-              <a:tblGrid>
-                <a:gridCol w="4479978">
-                  <a:extLst>
-                    <a:ext uri="{9D8B030D-6E8A-4147-A177-3AD203B41FA5}">
-                      <a16:colId xmlns:a16="http://schemas.microsoft.com/office/drawing/2014/main" val="3598916711"/>
-                    </a:ext>
-                  </a:extLst>
-                </a:gridCol>
-                <a:gridCol w="4479978">
-                  <a:extLst>
-                    <a:ext uri="{9D8B030D-6E8A-4147-A177-3AD203B41FA5}">
-                      <a16:colId xmlns:a16="http://schemas.microsoft.com/office/drawing/2014/main" val="3246062061"/>
-                    </a:ext>
-                  </a:extLst>
-                </a:gridCol>
-                <a:gridCol w="4479978">
-                  <a:extLst>
-                    <a:ext uri="{9D8B030D-6E8A-4147-A177-3AD203B41FA5}">
-                      <a16:colId xmlns:a16="http://schemas.microsoft.com/office/drawing/2014/main" val="2088018993"/>
-                    </a:ext>
-                  </a:extLst>
-                </a:gridCol>
-                <a:gridCol w="4479978">
-                  <a:extLst>
-                    <a:ext uri="{9D8B030D-6E8A-4147-A177-3AD203B41FA5}">
-                      <a16:colId xmlns:a16="http://schemas.microsoft.com/office/drawing/2014/main" val="218506349"/>
-                    </a:ext>
-                  </a:extLst>
-                </a:gridCol>
-              </a:tblGrid>
-              <a:tr h="370840">
-                <a:tc>
-                  <a:txBody>
-                    <a:bodyPr/>
-                    <a:lstStyle/>
-                    <a:p>
-                      <a:pPr algn="ctr"/>
-                      <a:r>
-                        <a:rPr lang="en-US" sz="3000" b="1" dirty="0">
-                          <a:latin typeface="EB Garamond" pitchFamily="2" charset="0"/>
-                          <a:ea typeface="EB Garamond" pitchFamily="2" charset="0"/>
-                        </a:rPr>
-                        <a:t>Outcome</a:t>
-                      </a:r>
-                    </a:p>
-                  </a:txBody>
-                  <a:tcPr/>
-                </a:tc>
-                <a:tc>
-                  <a:txBody>
-                    <a:bodyPr/>
-                    <a:lstStyle/>
-                    <a:p>
-                      <a:pPr algn="ctr"/>
-                      <a:r>
-                        <a:rPr lang="en-US" sz="3000" b="1" dirty="0">
-                          <a:latin typeface="EB Garamond" pitchFamily="2" charset="0"/>
-                          <a:ea typeface="EB Garamond" pitchFamily="2" charset="0"/>
-                        </a:rPr>
-                        <a:t>Uncertainty</a:t>
-                      </a:r>
-                    </a:p>
-                  </a:txBody>
-                  <a:tcPr/>
-                </a:tc>
-                <a:tc>
-                  <a:txBody>
-                    <a:bodyPr/>
-                    <a:lstStyle/>
-                    <a:p>
-                      <a:pPr algn="ctr"/>
-                      <a:r>
-                        <a:rPr lang="en-US" sz="3000" dirty="0">
-                          <a:latin typeface="EB Garamond" pitchFamily="2" charset="0"/>
-                          <a:ea typeface="EB Garamond" pitchFamily="2" charset="0"/>
-                        </a:rPr>
-                        <a:t>Burden</a:t>
-                      </a:r>
-                    </a:p>
-                  </a:txBody>
-                  <a:tcPr/>
-                </a:tc>
-                <a:tc>
-                  <a:txBody>
-                    <a:bodyPr/>
-                    <a:lstStyle/>
-                    <a:p>
-                      <a:pPr algn="ctr"/>
-                      <a:r>
-                        <a:rPr lang="en-US" sz="3000" dirty="0">
-                          <a:latin typeface="EB Garamond" pitchFamily="2" charset="0"/>
-                          <a:ea typeface="EB Garamond" pitchFamily="2" charset="0"/>
-                        </a:rPr>
-                        <a:t>Opportunity</a:t>
-                      </a:r>
-                    </a:p>
-                  </a:txBody>
-                  <a:tcPr/>
-                </a:tc>
-                <a:extLst>
-                  <a:ext uri="{0D108BD9-81ED-4DB2-BD59-A6C34878D82A}">
-                    <a16:rowId xmlns:a16="http://schemas.microsoft.com/office/drawing/2014/main" val="2793135608"/>
-                  </a:ext>
-                </a:extLst>
-              </a:tr>
-              <a:tr h="370840">
-                <a:tc>
-                  <a:txBody>
-                    <a:bodyPr/>
-                    <a:lstStyle/>
-                    <a:p>
-                      <a:r>
-                        <a:rPr lang="en-US" sz="3000" dirty="0">
-                          <a:solidFill>
-                            <a:schemeClr val="accent6"/>
-                          </a:solidFill>
-                          <a:latin typeface="EB Garamond" pitchFamily="2" charset="0"/>
-                          <a:ea typeface="EB Garamond" pitchFamily="2" charset="0"/>
-                        </a:rPr>
-                        <a:t>AI adoption </a:t>
-                      </a:r>
-                    </a:p>
-                  </a:txBody>
-                  <a:tcPr/>
-                </a:tc>
-                <a:tc>
-                  <a:txBody>
-                    <a:bodyPr/>
-                    <a:lstStyle/>
-                    <a:p>
-                      <a:endParaRPr lang="en-US" sz="3000" dirty="0">
-                        <a:solidFill>
-                          <a:schemeClr val="accent6"/>
-                        </a:solidFill>
-                        <a:latin typeface="EB Garamond" pitchFamily="2" charset="0"/>
-                        <a:ea typeface="EB Garamond" pitchFamily="2" charset="0"/>
-                      </a:endParaRPr>
-                    </a:p>
-                  </a:txBody>
-                  <a:tcPr/>
-                </a:tc>
-                <a:tc>
-                  <a:txBody>
-                    <a:bodyPr/>
-                    <a:lstStyle/>
-                    <a:p>
-                      <a:endParaRPr lang="en-US" sz="3000" dirty="0">
-                        <a:solidFill>
-                          <a:schemeClr val="accent6"/>
-                        </a:solidFill>
-                        <a:latin typeface="EB Garamond" pitchFamily="2" charset="0"/>
-                        <a:ea typeface="EB Garamond" pitchFamily="2" charset="0"/>
-                      </a:endParaRPr>
-                    </a:p>
-                  </a:txBody>
-                  <a:tcPr/>
-                </a:tc>
-                <a:tc>
-                  <a:txBody>
-                    <a:bodyPr/>
-                    <a:lstStyle/>
-                    <a:p>
-                      <a:endParaRPr lang="en-US" sz="3000" dirty="0">
-                        <a:solidFill>
-                          <a:schemeClr val="accent6"/>
-                        </a:solidFill>
-                        <a:latin typeface="EB Garamond" pitchFamily="2" charset="0"/>
-                        <a:ea typeface="EB Garamond" pitchFamily="2" charset="0"/>
-                      </a:endParaRPr>
-                    </a:p>
-                  </a:txBody>
-                  <a:tcPr/>
-                </a:tc>
-                <a:extLst>
-                  <a:ext uri="{0D108BD9-81ED-4DB2-BD59-A6C34878D82A}">
-                    <a16:rowId xmlns:a16="http://schemas.microsoft.com/office/drawing/2014/main" val="2905672559"/>
-                  </a:ext>
-                </a:extLst>
-              </a:tr>
-              <a:tr h="370840">
-                <a:tc>
-                  <a:txBody>
-                    <a:bodyPr/>
-                    <a:lstStyle/>
-                    <a:p>
-                      <a:r>
-                        <a:rPr lang="en-US" sz="3000" dirty="0">
-                          <a:solidFill>
-                            <a:schemeClr val="accent6"/>
-                          </a:solidFill>
-                          <a:latin typeface="EB Garamond" pitchFamily="2" charset="0"/>
-                          <a:ea typeface="EB Garamond" pitchFamily="2" charset="0"/>
-                        </a:rPr>
-                        <a:t>Innovation slowdown</a:t>
-                      </a:r>
-                    </a:p>
-                  </a:txBody>
-                  <a:tcPr/>
-                </a:tc>
-                <a:tc>
-                  <a:txBody>
-                    <a:bodyPr/>
-                    <a:lstStyle/>
-                    <a:p>
-                      <a:endParaRPr lang="en-US" sz="3000">
-                        <a:solidFill>
-                          <a:schemeClr val="accent6"/>
-                        </a:solidFill>
-                        <a:latin typeface="EB Garamond" pitchFamily="2" charset="0"/>
-                        <a:ea typeface="EB Garamond" pitchFamily="2" charset="0"/>
-                      </a:endParaRPr>
-                    </a:p>
-                  </a:txBody>
-                  <a:tcPr/>
-                </a:tc>
-                <a:tc>
-                  <a:txBody>
-                    <a:bodyPr/>
-                    <a:lstStyle/>
-                    <a:p>
-                      <a:endParaRPr lang="en-US" sz="3000">
-                        <a:solidFill>
-                          <a:schemeClr val="accent6"/>
-                        </a:solidFill>
-                        <a:latin typeface="EB Garamond" pitchFamily="2" charset="0"/>
-                        <a:ea typeface="EB Garamond" pitchFamily="2" charset="0"/>
-                      </a:endParaRPr>
-                    </a:p>
-                  </a:txBody>
-                  <a:tcPr/>
-                </a:tc>
-                <a:tc>
-                  <a:txBody>
-                    <a:bodyPr/>
-                    <a:lstStyle/>
-                    <a:p>
-                      <a:endParaRPr lang="en-US" sz="3000" dirty="0">
-                        <a:solidFill>
-                          <a:schemeClr val="accent6"/>
-                        </a:solidFill>
-                        <a:latin typeface="EB Garamond" pitchFamily="2" charset="0"/>
-                        <a:ea typeface="EB Garamond" pitchFamily="2" charset="0"/>
-                      </a:endParaRPr>
-                    </a:p>
-                  </a:txBody>
-                  <a:tcPr/>
-                </a:tc>
-                <a:extLst>
-                  <a:ext uri="{0D108BD9-81ED-4DB2-BD59-A6C34878D82A}">
-                    <a16:rowId xmlns:a16="http://schemas.microsoft.com/office/drawing/2014/main" val="1831389923"/>
-                  </a:ext>
-                </a:extLst>
-              </a:tr>
-              <a:tr h="370840">
-                <a:tc>
-                  <a:txBody>
-                    <a:bodyPr/>
-                    <a:lstStyle/>
-                    <a:p>
-                      <a:r>
-                        <a:rPr lang="en-US" sz="3000" dirty="0">
-                          <a:solidFill>
-                            <a:schemeClr val="accent6"/>
-                          </a:solidFill>
-                          <a:latin typeface="EB Garamond" pitchFamily="2" charset="0"/>
-                          <a:ea typeface="EB Garamond" pitchFamily="2" charset="0"/>
-                        </a:rPr>
-                        <a:t>Research sharing </a:t>
-                      </a:r>
-                      <a:r>
-                        <a:rPr lang="en-US" sz="3000" b="0" i="0" u="none" strike="noStrike" cap="none" dirty="0">
-                          <a:solidFill>
-                            <a:schemeClr val="accent6"/>
-                          </a:solidFill>
-                          <a:effectLst/>
-                          <a:latin typeface="EB Garamond" pitchFamily="2" charset="0"/>
-                          <a:ea typeface="EB Garamond" pitchFamily="2" charset="0"/>
-                          <a:cs typeface="+mn-cs"/>
-                          <a:sym typeface="Arial"/>
-                        </a:rPr>
-                        <a:t>↓</a:t>
-                      </a:r>
-                      <a:endParaRPr lang="en-US" sz="3000" dirty="0">
-                        <a:solidFill>
-                          <a:schemeClr val="accent6"/>
-                        </a:solidFill>
-                        <a:latin typeface="EB Garamond" pitchFamily="2" charset="0"/>
-                        <a:ea typeface="EB Garamond" pitchFamily="2" charset="0"/>
-                      </a:endParaRPr>
-                    </a:p>
-                  </a:txBody>
-                  <a:tcPr/>
-                </a:tc>
-                <a:tc>
-                  <a:txBody>
-                    <a:bodyPr/>
-                    <a:lstStyle/>
-                    <a:p>
-                      <a:endParaRPr lang="en-US" sz="3000">
-                        <a:solidFill>
-                          <a:schemeClr val="accent6"/>
-                        </a:solidFill>
-                        <a:latin typeface="EB Garamond" pitchFamily="2" charset="0"/>
-                        <a:ea typeface="EB Garamond" pitchFamily="2" charset="0"/>
-                      </a:endParaRPr>
-                    </a:p>
-                  </a:txBody>
-                  <a:tcPr/>
-                </a:tc>
-                <a:tc>
-                  <a:txBody>
-                    <a:bodyPr/>
-                    <a:lstStyle/>
-                    <a:p>
-                      <a:endParaRPr lang="en-US" sz="3000">
-                        <a:solidFill>
-                          <a:schemeClr val="accent6"/>
-                        </a:solidFill>
-                        <a:latin typeface="EB Garamond" pitchFamily="2" charset="0"/>
-                        <a:ea typeface="EB Garamond" pitchFamily="2" charset="0"/>
-                      </a:endParaRPr>
-                    </a:p>
-                  </a:txBody>
-                  <a:tcPr/>
-                </a:tc>
-                <a:tc>
-                  <a:txBody>
-                    <a:bodyPr/>
-                    <a:lstStyle/>
-                    <a:p>
-                      <a:endParaRPr lang="en-US" sz="3000" dirty="0">
-                        <a:solidFill>
-                          <a:schemeClr val="accent6"/>
-                        </a:solidFill>
-                        <a:latin typeface="EB Garamond" pitchFamily="2" charset="0"/>
-                        <a:ea typeface="EB Garamond" pitchFamily="2" charset="0"/>
-                      </a:endParaRPr>
-                    </a:p>
-                  </a:txBody>
-                  <a:tcPr/>
-                </a:tc>
-                <a:extLst>
-                  <a:ext uri="{0D108BD9-81ED-4DB2-BD59-A6C34878D82A}">
-                    <a16:rowId xmlns:a16="http://schemas.microsoft.com/office/drawing/2014/main" val="3827258114"/>
-                  </a:ext>
-                </a:extLst>
-              </a:tr>
-              <a:tr h="370840">
-                <a:tc>
-                  <a:txBody>
-                    <a:bodyPr/>
-                    <a:lstStyle/>
-                    <a:p>
-                      <a:r>
-                        <a:rPr lang="en-US" sz="3000" dirty="0">
-                          <a:solidFill>
-                            <a:schemeClr val="accent6"/>
-                          </a:solidFill>
-                          <a:latin typeface="EB Garamond" pitchFamily="2" charset="0"/>
-                          <a:ea typeface="EB Garamond" pitchFamily="2" charset="0"/>
-                        </a:rPr>
-                        <a:t>Business threat</a:t>
-                      </a:r>
-                    </a:p>
-                  </a:txBody>
-                  <a:tcPr/>
-                </a:tc>
-                <a:tc>
-                  <a:txBody>
-                    <a:bodyPr/>
-                    <a:lstStyle/>
-                    <a:p>
-                      <a:endParaRPr lang="en-US" sz="3000">
-                        <a:solidFill>
-                          <a:schemeClr val="accent6"/>
-                        </a:solidFill>
-                        <a:latin typeface="EB Garamond" pitchFamily="2" charset="0"/>
-                        <a:ea typeface="EB Garamond" pitchFamily="2" charset="0"/>
-                      </a:endParaRPr>
-                    </a:p>
-                  </a:txBody>
-                  <a:tcPr/>
-                </a:tc>
-                <a:tc>
-                  <a:txBody>
-                    <a:bodyPr/>
-                    <a:lstStyle/>
-                    <a:p>
-                      <a:endParaRPr lang="en-US" sz="3000">
-                        <a:solidFill>
-                          <a:schemeClr val="accent6"/>
-                        </a:solidFill>
-                        <a:latin typeface="EB Garamond" pitchFamily="2" charset="0"/>
-                        <a:ea typeface="EB Garamond" pitchFamily="2" charset="0"/>
-                      </a:endParaRPr>
-                    </a:p>
-                  </a:txBody>
-                  <a:tcPr/>
-                </a:tc>
-                <a:tc>
-                  <a:txBody>
-                    <a:bodyPr/>
-                    <a:lstStyle/>
-                    <a:p>
-                      <a:endParaRPr lang="en-US" sz="3000" dirty="0">
-                        <a:solidFill>
-                          <a:schemeClr val="accent6"/>
-                        </a:solidFill>
-                        <a:latin typeface="EB Garamond" pitchFamily="2" charset="0"/>
-                        <a:ea typeface="EB Garamond" pitchFamily="2" charset="0"/>
-                      </a:endParaRPr>
-                    </a:p>
-                  </a:txBody>
-                  <a:tcPr/>
-                </a:tc>
-                <a:extLst>
-                  <a:ext uri="{0D108BD9-81ED-4DB2-BD59-A6C34878D82A}">
-                    <a16:rowId xmlns:a16="http://schemas.microsoft.com/office/drawing/2014/main" val="4282952912"/>
-                  </a:ext>
-                </a:extLst>
-              </a:tr>
-              <a:tr h="370840">
-                <a:tc>
-                  <a:txBody>
-                    <a:bodyPr/>
-                    <a:lstStyle/>
-                    <a:p>
-                      <a:r>
-                        <a:rPr lang="en-US" sz="3000" dirty="0">
-                          <a:solidFill>
-                            <a:schemeClr val="accent6"/>
-                          </a:solidFill>
-                          <a:latin typeface="EB Garamond" pitchFamily="2" charset="0"/>
-                          <a:ea typeface="EB Garamond" pitchFamily="2" charset="0"/>
-                        </a:rPr>
-                        <a:t>Competitive disadvantage</a:t>
-                      </a:r>
-                    </a:p>
-                  </a:txBody>
-                  <a:tcPr/>
-                </a:tc>
-                <a:tc>
-                  <a:txBody>
-                    <a:bodyPr/>
-                    <a:lstStyle/>
-                    <a:p>
-                      <a:endParaRPr lang="en-US" sz="3000">
-                        <a:solidFill>
-                          <a:schemeClr val="accent6"/>
-                        </a:solidFill>
-                        <a:latin typeface="EB Garamond" pitchFamily="2" charset="0"/>
-                        <a:ea typeface="EB Garamond" pitchFamily="2" charset="0"/>
-                      </a:endParaRPr>
-                    </a:p>
-                  </a:txBody>
-                  <a:tcPr/>
-                </a:tc>
-                <a:tc>
-                  <a:txBody>
-                    <a:bodyPr/>
-                    <a:lstStyle/>
-                    <a:p>
-                      <a:endParaRPr lang="en-US" sz="3000">
-                        <a:solidFill>
-                          <a:schemeClr val="accent6"/>
-                        </a:solidFill>
-                        <a:latin typeface="EB Garamond" pitchFamily="2" charset="0"/>
-                        <a:ea typeface="EB Garamond" pitchFamily="2" charset="0"/>
-                      </a:endParaRPr>
-                    </a:p>
-                  </a:txBody>
-                  <a:tcPr/>
-                </a:tc>
-                <a:tc>
-                  <a:txBody>
-                    <a:bodyPr/>
-                    <a:lstStyle/>
-                    <a:p>
-                      <a:endParaRPr lang="en-US" sz="3000" dirty="0">
-                        <a:solidFill>
-                          <a:schemeClr val="accent6"/>
-                        </a:solidFill>
-                        <a:latin typeface="EB Garamond" pitchFamily="2" charset="0"/>
-                        <a:ea typeface="EB Garamond" pitchFamily="2" charset="0"/>
-                      </a:endParaRPr>
-                    </a:p>
-                  </a:txBody>
-                  <a:tcPr/>
-                </a:tc>
-                <a:extLst>
-                  <a:ext uri="{0D108BD9-81ED-4DB2-BD59-A6C34878D82A}">
-                    <a16:rowId xmlns:a16="http://schemas.microsoft.com/office/drawing/2014/main" val="4194392706"/>
-                  </a:ext>
-                </a:extLst>
-              </a:tr>
-              <a:tr h="370840">
-                <a:tc>
-                  <a:txBody>
-                    <a:bodyPr/>
-                    <a:lstStyle/>
-                    <a:p>
-                      <a:r>
-                        <a:rPr lang="en-US" sz="3000" dirty="0">
-                          <a:solidFill>
-                            <a:schemeClr val="accent6"/>
-                          </a:solidFill>
-                          <a:latin typeface="EB Garamond" pitchFamily="2" charset="0"/>
-                          <a:ea typeface="EB Garamond" pitchFamily="2" charset="0"/>
-                        </a:rPr>
-                        <a:t>Process standardization</a:t>
-                      </a:r>
-                    </a:p>
-                  </a:txBody>
-                  <a:tcPr/>
-                </a:tc>
-                <a:tc>
-                  <a:txBody>
-                    <a:bodyPr/>
-                    <a:lstStyle/>
-                    <a:p>
-                      <a:endParaRPr lang="en-US" sz="3000">
-                        <a:solidFill>
-                          <a:schemeClr val="accent6"/>
-                        </a:solidFill>
-                        <a:latin typeface="EB Garamond" pitchFamily="2" charset="0"/>
-                        <a:ea typeface="EB Garamond" pitchFamily="2" charset="0"/>
-                      </a:endParaRPr>
-                    </a:p>
-                  </a:txBody>
-                  <a:tcPr/>
-                </a:tc>
-                <a:tc>
-                  <a:txBody>
-                    <a:bodyPr/>
-                    <a:lstStyle/>
-                    <a:p>
-                      <a:endParaRPr lang="en-US" sz="3000">
-                        <a:solidFill>
-                          <a:schemeClr val="accent6"/>
-                        </a:solidFill>
-                        <a:latin typeface="EB Garamond" pitchFamily="2" charset="0"/>
-                        <a:ea typeface="EB Garamond" pitchFamily="2" charset="0"/>
-                      </a:endParaRPr>
-                    </a:p>
-                  </a:txBody>
-                  <a:tcPr/>
-                </a:tc>
-                <a:tc>
-                  <a:txBody>
-                    <a:bodyPr/>
-                    <a:lstStyle/>
-                    <a:p>
-                      <a:endParaRPr lang="en-US" sz="3000" dirty="0">
-                        <a:solidFill>
-                          <a:schemeClr val="accent6"/>
-                        </a:solidFill>
-                        <a:latin typeface="EB Garamond" pitchFamily="2" charset="0"/>
-                        <a:ea typeface="EB Garamond" pitchFamily="2" charset="0"/>
-                      </a:endParaRPr>
-                    </a:p>
-                  </a:txBody>
-                  <a:tcPr/>
-                </a:tc>
-                <a:extLst>
-                  <a:ext uri="{0D108BD9-81ED-4DB2-BD59-A6C34878D82A}">
-                    <a16:rowId xmlns:a16="http://schemas.microsoft.com/office/drawing/2014/main" val="1214247826"/>
-                  </a:ext>
-                </a:extLst>
-              </a:tr>
-              <a:tr h="370840">
-                <a:tc>
-                  <a:txBody>
-                    <a:bodyPr/>
-                    <a:lstStyle/>
-                    <a:p>
-                      <a:r>
-                        <a:rPr lang="en-US" sz="3000" dirty="0">
-                          <a:solidFill>
-                            <a:schemeClr val="accent6"/>
-                          </a:solidFill>
-                          <a:latin typeface="EB Garamond" pitchFamily="2" charset="0"/>
-                          <a:ea typeface="EB Garamond" pitchFamily="2" charset="0"/>
-                        </a:rPr>
-                        <a:t>Process optimization</a:t>
-                      </a:r>
-                    </a:p>
-                  </a:txBody>
-                  <a:tcPr/>
-                </a:tc>
-                <a:tc>
-                  <a:txBody>
-                    <a:bodyPr/>
-                    <a:lstStyle/>
-                    <a:p>
-                      <a:endParaRPr lang="en-US" sz="3000">
-                        <a:solidFill>
-                          <a:schemeClr val="accent6"/>
-                        </a:solidFill>
-                        <a:latin typeface="EB Garamond" pitchFamily="2" charset="0"/>
-                        <a:ea typeface="EB Garamond" pitchFamily="2" charset="0"/>
-                      </a:endParaRPr>
-                    </a:p>
-                  </a:txBody>
-                  <a:tcPr/>
-                </a:tc>
-                <a:tc>
-                  <a:txBody>
-                    <a:bodyPr/>
-                    <a:lstStyle/>
-                    <a:p>
-                      <a:endParaRPr lang="en-US" sz="3000">
-                        <a:solidFill>
-                          <a:schemeClr val="accent6"/>
-                        </a:solidFill>
-                        <a:latin typeface="EB Garamond" pitchFamily="2" charset="0"/>
-                        <a:ea typeface="EB Garamond" pitchFamily="2" charset="0"/>
-                      </a:endParaRPr>
-                    </a:p>
-                  </a:txBody>
-                  <a:tcPr/>
-                </a:tc>
-                <a:tc>
-                  <a:txBody>
-                    <a:bodyPr/>
-                    <a:lstStyle/>
-                    <a:p>
-                      <a:endParaRPr lang="en-US" sz="3000" dirty="0">
-                        <a:solidFill>
-                          <a:schemeClr val="accent6"/>
-                        </a:solidFill>
-                        <a:latin typeface="EB Garamond" pitchFamily="2" charset="0"/>
-                        <a:ea typeface="EB Garamond" pitchFamily="2" charset="0"/>
-                      </a:endParaRPr>
-                    </a:p>
-                  </a:txBody>
-                  <a:tcPr/>
-                </a:tc>
-                <a:extLst>
-                  <a:ext uri="{0D108BD9-81ED-4DB2-BD59-A6C34878D82A}">
-                    <a16:rowId xmlns:a16="http://schemas.microsoft.com/office/drawing/2014/main" val="1630723441"/>
-                  </a:ext>
-                </a:extLst>
-              </a:tr>
-              <a:tr h="370840">
-                <a:tc>
-                  <a:txBody>
-                    <a:bodyPr/>
-                    <a:lstStyle/>
-                    <a:p>
-                      <a:r>
-                        <a:rPr lang="en-US" sz="3000" dirty="0">
-                          <a:solidFill>
-                            <a:schemeClr val="accent6"/>
-                          </a:solidFill>
-                          <a:latin typeface="EB Garamond" pitchFamily="2" charset="0"/>
-                          <a:ea typeface="EB Garamond" pitchFamily="2" charset="0"/>
-                        </a:rPr>
-                        <a:t>Customer trust </a:t>
-                      </a:r>
-                      <a:r>
-                        <a:rPr lang="en-US" sz="3000" b="0" i="0" u="none" strike="noStrike" cap="none" dirty="0">
-                          <a:solidFill>
-                            <a:schemeClr val="accent6"/>
-                          </a:solidFill>
-                          <a:effectLst/>
-                          <a:latin typeface="EB Garamond" pitchFamily="2" charset="0"/>
-                          <a:ea typeface="EB Garamond" pitchFamily="2" charset="0"/>
-                          <a:cs typeface="+mn-cs"/>
-                          <a:sym typeface="Arial"/>
-                        </a:rPr>
-                        <a:t>↑</a:t>
-                      </a:r>
-                      <a:endParaRPr lang="en-US" sz="3000" dirty="0">
-                        <a:solidFill>
-                          <a:schemeClr val="accent6"/>
-                        </a:solidFill>
-                        <a:latin typeface="EB Garamond" pitchFamily="2" charset="0"/>
-                        <a:ea typeface="EB Garamond" pitchFamily="2" charset="0"/>
-                      </a:endParaRPr>
-                    </a:p>
-                  </a:txBody>
-                  <a:tcPr/>
-                </a:tc>
-                <a:tc>
-                  <a:txBody>
-                    <a:bodyPr/>
-                    <a:lstStyle/>
-                    <a:p>
-                      <a:endParaRPr lang="en-US" sz="3000" dirty="0">
-                        <a:solidFill>
-                          <a:schemeClr val="accent6"/>
-                        </a:solidFill>
-                        <a:latin typeface="EB Garamond" pitchFamily="2" charset="0"/>
-                        <a:ea typeface="EB Garamond" pitchFamily="2" charset="0"/>
-                      </a:endParaRPr>
-                    </a:p>
-                  </a:txBody>
-                  <a:tcPr/>
-                </a:tc>
-                <a:tc>
-                  <a:txBody>
-                    <a:bodyPr/>
-                    <a:lstStyle/>
-                    <a:p>
-                      <a:endParaRPr lang="en-US" sz="3000" dirty="0">
-                        <a:solidFill>
-                          <a:schemeClr val="accent6"/>
-                        </a:solidFill>
-                        <a:latin typeface="EB Garamond" pitchFamily="2" charset="0"/>
-                        <a:ea typeface="EB Garamond" pitchFamily="2" charset="0"/>
-                      </a:endParaRPr>
-                    </a:p>
-                  </a:txBody>
-                  <a:tcPr/>
-                </a:tc>
-                <a:tc>
-                  <a:txBody>
-                    <a:bodyPr/>
-                    <a:lstStyle/>
-                    <a:p>
-                      <a:endParaRPr lang="en-US" sz="3000" dirty="0">
-                        <a:solidFill>
-                          <a:schemeClr val="accent6"/>
-                        </a:solidFill>
-                        <a:latin typeface="EB Garamond" pitchFamily="2" charset="0"/>
-                        <a:ea typeface="EB Garamond" pitchFamily="2" charset="0"/>
-                      </a:endParaRPr>
-                    </a:p>
-                  </a:txBody>
-                  <a:tcPr/>
-                </a:tc>
-                <a:extLst>
-                  <a:ext uri="{0D108BD9-81ED-4DB2-BD59-A6C34878D82A}">
-                    <a16:rowId xmlns:a16="http://schemas.microsoft.com/office/drawing/2014/main" val="1352290575"/>
-                  </a:ext>
-                </a:extLst>
-              </a:tr>
-            </a:tbl>
-          </a:graphicData>
-        </a:graphic>
-      </p:graphicFrame>
+          <p:cNvPicPr>
+            <a:picLocks noChangeAspect="1"/>
+          </p:cNvPicPr>
+          <p:nvPr/>
+        </p:nvPicPr>
+        <p:blipFill>
+          <a:blip r:embed="rId5"/>
+          <a:stretch>
+            <a:fillRect/>
+          </a:stretch>
+        </p:blipFill>
+        <p:spPr>
+          <a:xfrm>
+            <a:off x="11358611" y="18735977"/>
+            <a:ext cx="21434187" cy="7891445"/>
+          </a:xfrm>
+          <a:prstGeom prst="rect">
+            <a:avLst/>
+          </a:prstGeom>
+        </p:spPr>
+      </p:pic>
+      <p:sp>
+        <p:nvSpPr>
+          <p:cNvPr id="15" name="Google Shape;98;p1">
+            <a:extLst>
+              <a:ext uri="{FF2B5EF4-FFF2-40B4-BE49-F238E27FC236}">
+                <a16:creationId xmlns:a16="http://schemas.microsoft.com/office/drawing/2014/main" id="{F60F2BDC-4018-D770-7846-6665609DAF05}"/>
+              </a:ext>
+            </a:extLst>
+          </p:cNvPr>
+          <p:cNvSpPr/>
+          <p:nvPr/>
+        </p:nvSpPr>
+        <p:spPr>
+          <a:xfrm>
+            <a:off x="32994785" y="16819014"/>
+            <a:ext cx="10241280" cy="914400"/>
+          </a:xfrm>
+          <a:prstGeom prst="rect">
+            <a:avLst/>
+          </a:prstGeom>
+          <a:solidFill>
+            <a:srgbClr val="9C2334"/>
+          </a:solidFill>
+          <a:ln>
+            <a:noFill/>
+          </a:ln>
+          <a:effectLst>
+            <a:outerShdw blurRad="50800" dist="38100" dir="5400000" algn="t" rotWithShape="0">
+              <a:srgbClr val="000000">
+                <a:alpha val="40000"/>
+              </a:srgbClr>
+            </a:outerShdw>
+          </a:effectLst>
+        </p:spPr>
+        <p:txBody>
+          <a:bodyPr spcFirstLastPara="1" wrap="square" lIns="91425" tIns="45700" rIns="91425" bIns="45700" anchor="ctr" anchorCtr="0">
+            <a:noAutofit/>
+          </a:bodyPr>
+          <a:lstStyle/>
+          <a:p>
+            <a:pPr marL="0" marR="0" lvl="0" indent="0" algn="ctr" rtl="0">
+              <a:spcBef>
+                <a:spcPts val="0"/>
+              </a:spcBef>
+              <a:spcAft>
+                <a:spcPts val="0"/>
+              </a:spcAft>
+              <a:buNone/>
+            </a:pPr>
+            <a:endParaRPr sz="8600">
+              <a:solidFill>
+                <a:schemeClr val="lt1"/>
+              </a:solidFill>
+              <a:latin typeface="Corbel"/>
+              <a:ea typeface="Corbel"/>
+              <a:cs typeface="Corbel"/>
+              <a:sym typeface="Corbel"/>
+            </a:endParaRPr>
+          </a:p>
+        </p:txBody>
+      </p:sp>
+      <p:sp>
+        <p:nvSpPr>
+          <p:cNvPr id="16" name="Google Shape;99;p1">
+            <a:extLst>
+              <a:ext uri="{FF2B5EF4-FFF2-40B4-BE49-F238E27FC236}">
+                <a16:creationId xmlns:a16="http://schemas.microsoft.com/office/drawing/2014/main" id="{682F1A71-0B46-7E04-8B0D-E92D917112B8}"/>
+              </a:ext>
+            </a:extLst>
+          </p:cNvPr>
+          <p:cNvSpPr txBox="1"/>
+          <p:nvPr/>
+        </p:nvSpPr>
+        <p:spPr>
+          <a:xfrm>
+            <a:off x="33494848" y="16846754"/>
+            <a:ext cx="9083675" cy="769938"/>
+          </a:xfrm>
+          <a:prstGeom prst="rect">
+            <a:avLst/>
+          </a:prstGeom>
+          <a:noFill/>
+          <a:ln>
+            <a:noFill/>
+          </a:ln>
+          <a:effectLst>
+            <a:outerShdw blurRad="40000" dist="20000" dir="5400000" rotWithShape="0">
+              <a:srgbClr val="000000">
+                <a:alpha val="37647"/>
+              </a:srgbClr>
+            </a:outerShdw>
+          </a:effectLst>
+        </p:spPr>
+        <p:txBody>
+          <a:bodyPr spcFirstLastPara="1" wrap="square" lIns="91425" tIns="45700" rIns="91425" bIns="45700" anchor="t" anchorCtr="0">
+            <a:spAutoFit/>
+          </a:bodyPr>
+          <a:lstStyle/>
+          <a:p>
+            <a:pPr marL="0" marR="0" lvl="0" indent="0" algn="ctr" rtl="0">
+              <a:spcBef>
+                <a:spcPts val="0"/>
+              </a:spcBef>
+              <a:spcAft>
+                <a:spcPts val="0"/>
+              </a:spcAft>
+              <a:buNone/>
+            </a:pPr>
+            <a:r>
+              <a:rPr lang="en-US" sz="4400" dirty="0">
+                <a:solidFill>
+                  <a:schemeClr val="lt1"/>
+                </a:solidFill>
+                <a:latin typeface="Verdana"/>
+                <a:ea typeface="Verdana"/>
+                <a:cs typeface="Verdana"/>
+                <a:sym typeface="Verdana"/>
+              </a:rPr>
+              <a:t>THEORETICAL FRAMEWORK</a:t>
+            </a:r>
+            <a:endParaRPr dirty="0"/>
+          </a:p>
+        </p:txBody>
+      </p:sp>
+      <p:sp>
+        <p:nvSpPr>
+          <p:cNvPr id="17" name="Google Shape;91;p1">
+            <a:extLst>
+              <a:ext uri="{FF2B5EF4-FFF2-40B4-BE49-F238E27FC236}">
+                <a16:creationId xmlns:a16="http://schemas.microsoft.com/office/drawing/2014/main" id="{782B9A74-2B29-DF8E-B98E-62ECC8EFDEBF}"/>
+              </a:ext>
+            </a:extLst>
+          </p:cNvPr>
+          <p:cNvSpPr txBox="1"/>
+          <p:nvPr/>
+        </p:nvSpPr>
+        <p:spPr>
+          <a:xfrm>
+            <a:off x="33027245" y="18046884"/>
+            <a:ext cx="10018879" cy="2400617"/>
+          </a:xfrm>
+          <a:prstGeom prst="rect">
+            <a:avLst/>
+          </a:prstGeom>
+          <a:noFill/>
+          <a:ln w="28575">
+            <a:solidFill>
+              <a:schemeClr val="tx1"/>
+            </a:solidFill>
+          </a:ln>
+        </p:spPr>
+        <p:txBody>
+          <a:bodyPr spcFirstLastPara="1" wrap="square" lIns="91425" tIns="45700" rIns="91425" bIns="45700" anchor="t" anchorCtr="0">
+            <a:spAutoFit/>
+          </a:bodyPr>
+          <a:lstStyle/>
+          <a:p>
+            <a:pPr algn="ctr"/>
+            <a:r>
+              <a:rPr lang="en-US" sz="3000" dirty="0">
+                <a:latin typeface="EB Garamond" pitchFamily="2" charset="0"/>
+                <a:ea typeface="EB Garamond" pitchFamily="2" charset="0"/>
+              </a:rPr>
+              <a:t>Regulatory Uncertainty</a:t>
+            </a:r>
+          </a:p>
+          <a:p>
+            <a:pPr algn="ctr"/>
+            <a:r>
+              <a:rPr lang="en-US" sz="3000" dirty="0">
+                <a:latin typeface="EB Garamond" pitchFamily="2" charset="0"/>
+                <a:ea typeface="EB Garamond" pitchFamily="2" charset="0"/>
+              </a:rPr>
+              <a:t>↓</a:t>
+            </a:r>
+          </a:p>
+          <a:p>
+            <a:pPr algn="ctr"/>
+            <a:r>
+              <a:rPr lang="en-US" sz="3000" dirty="0">
+                <a:latin typeface="EB Garamond" pitchFamily="2" charset="0"/>
+                <a:ea typeface="EB Garamond" pitchFamily="2" charset="0"/>
+              </a:rPr>
+              <a:t>Legal Ambiguity </a:t>
+            </a:r>
+            <a:r>
+              <a:rPr lang="en-US" sz="3000" dirty="0">
+                <a:latin typeface="EB Garamond" pitchFamily="2" charset="0"/>
+                <a:ea typeface="EB Garamond" pitchFamily="2" charset="0"/>
+                <a:sym typeface="Wingdings" pitchFamily="2" charset="2"/>
+              </a:rPr>
+              <a:t> Avoidance Behavior</a:t>
+            </a:r>
+          </a:p>
+          <a:p>
+            <a:pPr algn="ctr"/>
+            <a:r>
+              <a:rPr lang="en-US" sz="3000" dirty="0">
+                <a:latin typeface="EB Garamond" pitchFamily="2" charset="0"/>
+                <a:ea typeface="EB Garamond" pitchFamily="2" charset="0"/>
+              </a:rPr>
+              <a:t>↓ </a:t>
+            </a:r>
+          </a:p>
+          <a:p>
+            <a:pPr algn="ctr"/>
+            <a:r>
+              <a:rPr lang="en-US" sz="3000" dirty="0">
+                <a:latin typeface="EB Garamond" pitchFamily="2" charset="0"/>
+                <a:ea typeface="EB Garamond" pitchFamily="2" charset="0"/>
+                <a:sym typeface="Wingdings" pitchFamily="2" charset="2"/>
+              </a:rPr>
+              <a:t>Reduced AI Adoption and Data Sharing</a:t>
+            </a:r>
+          </a:p>
+        </p:txBody>
+      </p:sp>
+      <p:sp>
+        <p:nvSpPr>
+          <p:cNvPr id="18" name="TextBox 17">
+            <a:extLst>
+              <a:ext uri="{FF2B5EF4-FFF2-40B4-BE49-F238E27FC236}">
+                <a16:creationId xmlns:a16="http://schemas.microsoft.com/office/drawing/2014/main" id="{9DC4E778-F44F-6802-B640-1D4176C22AB8}"/>
+              </a:ext>
+            </a:extLst>
+          </p:cNvPr>
+          <p:cNvSpPr txBox="1"/>
+          <p:nvPr/>
+        </p:nvSpPr>
+        <p:spPr>
+          <a:xfrm>
+            <a:off x="33027244" y="20664719"/>
+            <a:ext cx="10018879" cy="1477328"/>
+          </a:xfrm>
+          <a:prstGeom prst="rect">
+            <a:avLst/>
+          </a:prstGeom>
+          <a:noFill/>
+          <a:ln w="28575">
+            <a:solidFill>
+              <a:schemeClr val="tx1"/>
+            </a:solidFill>
+          </a:ln>
+        </p:spPr>
+        <p:txBody>
+          <a:bodyPr wrap="square" rtlCol="0">
+            <a:spAutoFit/>
+          </a:bodyPr>
+          <a:lstStyle/>
+          <a:p>
+            <a:pPr algn="ctr"/>
+            <a:r>
+              <a:rPr lang="en-US" sz="3000" dirty="0">
+                <a:latin typeface="EB Garamond" pitchFamily="2" charset="0"/>
+                <a:ea typeface="EB Garamond" pitchFamily="2" charset="0"/>
+                <a:sym typeface="Wingdings" pitchFamily="2" charset="2"/>
+              </a:rPr>
+              <a:t>Compliance Burden</a:t>
+            </a:r>
+          </a:p>
+          <a:p>
+            <a:pPr algn="ctr"/>
+            <a:r>
+              <a:rPr lang="en-US" sz="3000" dirty="0">
+                <a:latin typeface="EB Garamond" pitchFamily="2" charset="0"/>
+                <a:ea typeface="EB Garamond" pitchFamily="2" charset="0"/>
+              </a:rPr>
+              <a:t>↓ </a:t>
+            </a:r>
+          </a:p>
+          <a:p>
+            <a:pPr algn="ctr"/>
+            <a:r>
+              <a:rPr lang="en-US" sz="3000" dirty="0">
+                <a:latin typeface="EB Garamond" pitchFamily="2" charset="0"/>
+                <a:ea typeface="EB Garamond" pitchFamily="2" charset="0"/>
+              </a:rPr>
+              <a:t>Cost Pressure  </a:t>
+            </a:r>
+            <a:r>
+              <a:rPr lang="en-US" sz="3000" dirty="0">
+                <a:latin typeface="EB Garamond" pitchFamily="2" charset="0"/>
+                <a:ea typeface="EB Garamond" pitchFamily="2" charset="0"/>
+                <a:sym typeface="Wingdings" pitchFamily="2" charset="2"/>
+              </a:rPr>
+              <a:t> Innovation Constraint</a:t>
+            </a:r>
+          </a:p>
+        </p:txBody>
+      </p:sp>
+      <p:sp>
+        <p:nvSpPr>
+          <p:cNvPr id="21" name="TextBox 20">
+            <a:extLst>
+              <a:ext uri="{FF2B5EF4-FFF2-40B4-BE49-F238E27FC236}">
+                <a16:creationId xmlns:a16="http://schemas.microsoft.com/office/drawing/2014/main" id="{220EF7E4-A3BE-3C34-9EE4-E8946E0833EC}"/>
+              </a:ext>
+            </a:extLst>
+          </p:cNvPr>
+          <p:cNvSpPr txBox="1"/>
+          <p:nvPr/>
+        </p:nvSpPr>
+        <p:spPr>
+          <a:xfrm>
+            <a:off x="33027243" y="22367122"/>
+            <a:ext cx="10018879" cy="1477328"/>
+          </a:xfrm>
+          <a:prstGeom prst="rect">
+            <a:avLst/>
+          </a:prstGeom>
+          <a:noFill/>
+          <a:ln w="28575">
+            <a:solidFill>
+              <a:schemeClr val="tx1"/>
+            </a:solidFill>
+          </a:ln>
+        </p:spPr>
+        <p:txBody>
+          <a:bodyPr wrap="square" rtlCol="0">
+            <a:spAutoFit/>
+          </a:bodyPr>
+          <a:lstStyle/>
+          <a:p>
+            <a:pPr algn="ctr"/>
+            <a:r>
+              <a:rPr lang="en-US" sz="3000" dirty="0">
+                <a:latin typeface="EB Garamond" pitchFamily="2" charset="0"/>
+                <a:ea typeface="EB Garamond" pitchFamily="2" charset="0"/>
+              </a:rPr>
+              <a:t>Opportunity Orientation</a:t>
+            </a:r>
+            <a:br>
+              <a:rPr lang="en-US" sz="3000" dirty="0">
+                <a:latin typeface="EB Garamond" pitchFamily="2" charset="0"/>
+                <a:ea typeface="EB Garamond" pitchFamily="2" charset="0"/>
+              </a:rPr>
+            </a:br>
+            <a:r>
+              <a:rPr lang="en-US" sz="3000" dirty="0">
+                <a:latin typeface="EB Garamond" pitchFamily="2" charset="0"/>
+                <a:ea typeface="EB Garamond" pitchFamily="2" charset="0"/>
+              </a:rPr>
+              <a:t>↓</a:t>
+            </a:r>
+            <a:br>
+              <a:rPr lang="en-US" sz="3000" dirty="0">
+                <a:latin typeface="EB Garamond" pitchFamily="2" charset="0"/>
+                <a:ea typeface="EB Garamond" pitchFamily="2" charset="0"/>
+              </a:rPr>
+            </a:br>
+            <a:r>
+              <a:rPr lang="en-US" sz="3000" dirty="0">
+                <a:latin typeface="EB Garamond" pitchFamily="2" charset="0"/>
+                <a:ea typeface="EB Garamond" pitchFamily="2" charset="0"/>
+              </a:rPr>
+              <a:t>Strategic Framing à Competitive Gain</a:t>
+            </a:r>
+            <a:endParaRPr lang="en-US" sz="3000" dirty="0">
+              <a:latin typeface="EB Garamond" pitchFamily="2" charset="0"/>
+              <a:ea typeface="EB Garamond" pitchFamily="2" charset="0"/>
+              <a:sym typeface="Wingdings" pitchFamily="2" charset="2"/>
+            </a:endParaRPr>
+          </a:p>
+        </p:txBody>
+      </p:sp>
     </p:spTree>
   </p:cSld>
   <p:clrMapOvr>

</xml_diff>